<commit_message>
Add business-scenario tests (macro views): rates, war, taxes
39 tests (tests/test_business_scenarios.py) covering what happens to the output
when a client voices a macro view — a rate hike/cut, a war (or its end) asking
for alternatives, a tax rise/cut — delivered as either a tactical instruction or
a document. Each pins the product contract:
  1. the scenario reaches the AI verbatim (it's in the prompt),
  2. it SHAPES the advisory commentary (the write-up reflects it),
  3. it does NOT move the computed figures — FACTS identical with/without it
     (a macro opinion never invents or alters a number),
  4. the interest-rate tool reports bond exposure but refuses to fabricate an
     unsourced +100bp impact.

Report generator picks up the new file; summary-card counts are now computed
dynamically (added a Business layer). Suite: 69 -> 108 tests; reports regenerated.

Co-Authored-By: Claude Opus 4.8 <noreply@anthropic.com>
</commit_message>
<xml_diff>
--- a/Meridian_Copilot_Test_Report_v10.pptx
+++ b/Meridian_Copilot_Test_Report_v10.pptx
@@ -15,6 +15,7 @@
     <p:sldId id="263" r:id="rId14"/>
     <p:sldId id="264" r:id="rId15"/>
     <p:sldId id="265" r:id="rId16"/>
+    <p:sldId id="266" r:id="rId17"/>
   </p:sldIdLst>
   <p:sldSz cx="12191695" cy="6858000" type="screen4x3"/>
   <p:notesSz cx="6858000" cy="9144000"/>
@@ -3336,7 +3337,7 @@
                 </a:solidFill>
                 <a:latin typeface="Calibri"/>
               </a:rPr>
-              <a:t>69/69 tests passed   ·   15 July 2026</a:t>
+              <a:t>108/108 tests passed   ·   16 July 2026</a:t>
             </a:r>
           </a:p>
         </p:txBody>
@@ -3407,7 +3408,7 @@
         <p:spPr>
           <a:xfrm>
             <a:off x="0" y="0"/>
-            <a:ext cx="12191695" cy="6858000"/>
+            <a:ext cx="12191695" cy="1051560"/>
           </a:xfrm>
           <a:prstGeom prst="rect">
             <a:avLst/>
@@ -3450,8 +3451,8 @@
         </p:nvSpPr>
         <p:spPr>
           <a:xfrm>
-            <a:off x="0" y="6601968"/>
-            <a:ext cx="12191695" cy="256032"/>
+            <a:off x="0" y="1051560"/>
+            <a:ext cx="12191695" cy="73152"/>
           </a:xfrm>
           <a:prstGeom prst="rect">
             <a:avLst/>
@@ -3494,6 +3495,1012 @@
         </p:nvSpPr>
         <p:spPr>
           <a:xfrm>
+            <a:off x="640080" y="201168"/>
+            <a:ext cx="8686800" cy="457200"/>
+          </a:xfrm>
+          <a:prstGeom prst="rect">
+            <a:avLst/>
+          </a:prstGeom>
+          <a:noFill/>
+        </p:spPr>
+        <p:txBody>
+          <a:bodyPr wrap="square" anchor="t" lIns="0" rIns="0" tIns="0" bIns="0">
+            <a:spAutoFit/>
+          </a:bodyPr>
+          <a:lstStyle/>
+          <a:p>
+            <a:pPr algn="l">
+              <a:spcAft>
+                <a:spcPts val="200"/>
+              </a:spcAft>
+            </a:pPr>
+            <a:r>
+              <a:rPr sz="2600" b="1">
+                <a:solidFill>
+                  <a:srgbClr val="FFFFFF"/>
+                </a:solidFill>
+                <a:latin typeface="Calibri"/>
+              </a:rPr>
+              <a:t>Business scenarios</a:t>
+            </a:r>
+          </a:p>
+        </p:txBody>
+      </p:sp>
+      <p:sp>
+        <p:nvSpPr>
+          <p:cNvPr id="5" name="TextBox 4"/>
+          <p:cNvSpPr txBox="1"/>
+          <p:nvPr/>
+        </p:nvSpPr>
+        <p:spPr>
+          <a:xfrm>
+            <a:off x="640080" y="713232"/>
+            <a:ext cx="8686800" cy="274320"/>
+          </a:xfrm>
+          <a:prstGeom prst="rect">
+            <a:avLst/>
+          </a:prstGeom>
+          <a:noFill/>
+        </p:spPr>
+        <p:txBody>
+          <a:bodyPr wrap="square" anchor="t" lIns="0" rIns="0" tIns="0" bIns="0">
+            <a:spAutoFit/>
+          </a:bodyPr>
+          <a:lstStyle/>
+          <a:p>
+            <a:pPr algn="l">
+              <a:spcAft>
+                <a:spcPts val="200"/>
+              </a:spcAft>
+            </a:pPr>
+            <a:r>
+              <a:rPr sz="1200" b="0">
+                <a:solidFill>
+                  <a:srgbClr val="C8CDDD"/>
+                </a:solidFill>
+                <a:latin typeface="Calibri"/>
+              </a:rPr>
+              <a:t>Business  ·  tests/test_business_scenarios.py</a:t>
+            </a:r>
+          </a:p>
+        </p:txBody>
+      </p:sp>
+      <p:sp>
+        <p:nvSpPr>
+          <p:cNvPr id="6" name="TextBox 5"/>
+          <p:cNvSpPr txBox="1"/>
+          <p:nvPr/>
+        </p:nvSpPr>
+        <p:spPr>
+          <a:xfrm>
+            <a:off x="9814255" y="274320"/>
+            <a:ext cx="1828800" cy="548640"/>
+          </a:xfrm>
+          <a:prstGeom prst="rect">
+            <a:avLst/>
+          </a:prstGeom>
+          <a:noFill/>
+        </p:spPr>
+        <p:txBody>
+          <a:bodyPr wrap="square" anchor="t" lIns="0" rIns="0" tIns="0" bIns="0">
+            <a:spAutoFit/>
+          </a:bodyPr>
+          <a:lstStyle/>
+          <a:p>
+            <a:pPr algn="r">
+              <a:spcAft>
+                <a:spcPts val="200"/>
+              </a:spcAft>
+            </a:pPr>
+            <a:r>
+              <a:rPr sz="2000" b="1">
+                <a:solidFill>
+                  <a:srgbClr val="7FD1A0"/>
+                </a:solidFill>
+                <a:latin typeface="Calibri"/>
+              </a:rPr>
+              <a:t>39/39 PASS</a:t>
+            </a:r>
+          </a:p>
+        </p:txBody>
+      </p:sp>
+      <p:sp>
+        <p:nvSpPr>
+          <p:cNvPr id="7" name="TextBox 6"/>
+          <p:cNvSpPr txBox="1"/>
+          <p:nvPr/>
+        </p:nvSpPr>
+        <p:spPr>
+          <a:xfrm>
+            <a:off x="640080" y="1280160"/>
+            <a:ext cx="10972800" cy="457200"/>
+          </a:xfrm>
+          <a:prstGeom prst="rect">
+            <a:avLst/>
+          </a:prstGeom>
+          <a:noFill/>
+        </p:spPr>
+        <p:txBody>
+          <a:bodyPr wrap="square" anchor="t" lIns="0" rIns="0" tIns="0" bIns="0">
+            <a:spAutoFit/>
+          </a:bodyPr>
+          <a:lstStyle/>
+          <a:p>
+            <a:pPr algn="l">
+              <a:spcAft>
+                <a:spcPts val="200"/>
+              </a:spcAft>
+            </a:pPr>
+            <a:r>
+              <a:rPr sz="1300" b="0">
+                <a:solidFill>
+                  <a:srgbClr val="47517A"/>
+                </a:solidFill>
+                <a:latin typeface="Calibri"/>
+              </a:rPr>
+              <a:t>What happens to the output on a client macro view — a rate hike/cut, a war (or its end) prompting alternatives, a tax rise/cut: it reaches the AI, shapes the commentary, and never moves the grounded figures.</a:t>
+            </a:r>
+          </a:p>
+        </p:txBody>
+      </p:sp>
+      <p:sp>
+        <p:nvSpPr>
+          <p:cNvPr id="8" name="Rectangle 7"/>
+          <p:cNvSpPr/>
+          <p:nvPr/>
+        </p:nvSpPr>
+        <p:spPr>
+          <a:xfrm>
+            <a:off x="640080" y="1965960"/>
+            <a:ext cx="10881360" cy="347472"/>
+          </a:xfrm>
+          <a:prstGeom prst="rect">
+            <a:avLst/>
+          </a:prstGeom>
+          <a:solidFill>
+            <a:srgbClr val="FFFFFF"/>
+          </a:solidFill>
+          <a:ln w="12700">
+            <a:solidFill>
+              <a:srgbClr val="C8CDDD"/>
+            </a:solidFill>
+          </a:ln>
+          <a:effectLst/>
+        </p:spPr>
+        <p:style>
+          <a:lnRef idx="1">
+            <a:schemeClr val="accent1"/>
+          </a:lnRef>
+          <a:fillRef idx="3">
+            <a:schemeClr val="accent1"/>
+          </a:fillRef>
+          <a:effectRef idx="2">
+            <a:schemeClr val="accent1"/>
+          </a:effectRef>
+          <a:fontRef idx="minor">
+            <a:schemeClr val="lt1"/>
+          </a:fontRef>
+        </p:style>
+        <p:txBody>
+          <a:bodyPr rtlCol="0" anchor="ctr"/>
+          <a:lstStyle/>
+          <a:p>
+            <a:pPr algn="ctr"/>
+          </a:p>
+        </p:txBody>
+      </p:sp>
+      <p:sp>
+        <p:nvSpPr>
+          <p:cNvPr id="9" name="TextBox 8"/>
+          <p:cNvSpPr txBox="1"/>
+          <p:nvPr/>
+        </p:nvSpPr>
+        <p:spPr>
+          <a:xfrm>
+            <a:off x="822960" y="2011680"/>
+            <a:ext cx="457200" cy="274320"/>
+          </a:xfrm>
+          <a:prstGeom prst="rect">
+            <a:avLst/>
+          </a:prstGeom>
+          <a:noFill/>
+        </p:spPr>
+        <p:txBody>
+          <a:bodyPr wrap="square" anchor="t" lIns="0" rIns="0" tIns="0" bIns="0">
+            <a:spAutoFit/>
+          </a:bodyPr>
+          <a:lstStyle/>
+          <a:p>
+            <a:pPr algn="l">
+              <a:spcAft>
+                <a:spcPts val="200"/>
+              </a:spcAft>
+            </a:pPr>
+            <a:r>
+              <a:rPr sz="1300" b="1">
+                <a:solidFill>
+                  <a:srgbClr val="2E7D52"/>
+                </a:solidFill>
+                <a:latin typeface="Calibri"/>
+              </a:rPr>
+              <a:t>✓</a:t>
+            </a:r>
+          </a:p>
+        </p:txBody>
+      </p:sp>
+      <p:sp>
+        <p:nvSpPr>
+          <p:cNvPr id="10" name="TextBox 9"/>
+          <p:cNvSpPr txBox="1"/>
+          <p:nvPr/>
+        </p:nvSpPr>
+        <p:spPr>
+          <a:xfrm>
+            <a:off x="1325880" y="1993392"/>
+            <a:ext cx="10058400" cy="365760"/>
+          </a:xfrm>
+          <a:prstGeom prst="rect">
+            <a:avLst/>
+          </a:prstGeom>
+          <a:noFill/>
+        </p:spPr>
+        <p:txBody>
+          <a:bodyPr wrap="square" anchor="ctr" lIns="0" rIns="0" tIns="0" bIns="0">
+            <a:spAutoFit/>
+          </a:bodyPr>
+          <a:lstStyle/>
+          <a:p>
+            <a:pPr algn="l">
+              <a:spcAft>
+                <a:spcPts val="200"/>
+              </a:spcAft>
+            </a:pPr>
+            <a:r>
+              <a:rPr sz="1250" b="0">
+                <a:solidFill>
+                  <a:srgbClr val="16203C"/>
+                </a:solidFill>
+                <a:latin typeface="Calibri"/>
+              </a:rPr>
+              <a:t>A client macro view (rate/war/tax) reaches the AI verbatim. (12×)</a:t>
+            </a:r>
+          </a:p>
+        </p:txBody>
+      </p:sp>
+      <p:sp>
+        <p:nvSpPr>
+          <p:cNvPr id="11" name="Rectangle 10"/>
+          <p:cNvSpPr/>
+          <p:nvPr/>
+        </p:nvSpPr>
+        <p:spPr>
+          <a:xfrm>
+            <a:off x="640080" y="2386584"/>
+            <a:ext cx="10881360" cy="347472"/>
+          </a:xfrm>
+          <a:prstGeom prst="rect">
+            <a:avLst/>
+          </a:prstGeom>
+          <a:solidFill>
+            <a:srgbClr val="F4F6FB"/>
+          </a:solidFill>
+          <a:ln w="12700">
+            <a:solidFill>
+              <a:srgbClr val="C8CDDD"/>
+            </a:solidFill>
+          </a:ln>
+          <a:effectLst/>
+        </p:spPr>
+        <p:style>
+          <a:lnRef idx="1">
+            <a:schemeClr val="accent1"/>
+          </a:lnRef>
+          <a:fillRef idx="3">
+            <a:schemeClr val="accent1"/>
+          </a:fillRef>
+          <a:effectRef idx="2">
+            <a:schemeClr val="accent1"/>
+          </a:effectRef>
+          <a:fontRef idx="minor">
+            <a:schemeClr val="lt1"/>
+          </a:fontRef>
+        </p:style>
+        <p:txBody>
+          <a:bodyPr rtlCol="0" anchor="ctr"/>
+          <a:lstStyle/>
+          <a:p>
+            <a:pPr algn="ctr"/>
+          </a:p>
+        </p:txBody>
+      </p:sp>
+      <p:sp>
+        <p:nvSpPr>
+          <p:cNvPr id="12" name="TextBox 11"/>
+          <p:cNvSpPr txBox="1"/>
+          <p:nvPr/>
+        </p:nvSpPr>
+        <p:spPr>
+          <a:xfrm>
+            <a:off x="822960" y="2432304"/>
+            <a:ext cx="457200" cy="274320"/>
+          </a:xfrm>
+          <a:prstGeom prst="rect">
+            <a:avLst/>
+          </a:prstGeom>
+          <a:noFill/>
+        </p:spPr>
+        <p:txBody>
+          <a:bodyPr wrap="square" anchor="t" lIns="0" rIns="0" tIns="0" bIns="0">
+            <a:spAutoFit/>
+          </a:bodyPr>
+          <a:lstStyle/>
+          <a:p>
+            <a:pPr algn="l">
+              <a:spcAft>
+                <a:spcPts val="200"/>
+              </a:spcAft>
+            </a:pPr>
+            <a:r>
+              <a:rPr sz="1300" b="1">
+                <a:solidFill>
+                  <a:srgbClr val="2E7D52"/>
+                </a:solidFill>
+                <a:latin typeface="Calibri"/>
+              </a:rPr>
+              <a:t>✓</a:t>
+            </a:r>
+          </a:p>
+        </p:txBody>
+      </p:sp>
+      <p:sp>
+        <p:nvSpPr>
+          <p:cNvPr id="13" name="TextBox 12"/>
+          <p:cNvSpPr txBox="1"/>
+          <p:nvPr/>
+        </p:nvSpPr>
+        <p:spPr>
+          <a:xfrm>
+            <a:off x="1325880" y="2414016"/>
+            <a:ext cx="10058400" cy="365760"/>
+          </a:xfrm>
+          <a:prstGeom prst="rect">
+            <a:avLst/>
+          </a:prstGeom>
+          <a:noFill/>
+        </p:spPr>
+        <p:txBody>
+          <a:bodyPr wrap="square" anchor="ctr" lIns="0" rIns="0" tIns="0" bIns="0">
+            <a:spAutoFit/>
+          </a:bodyPr>
+          <a:lstStyle/>
+          <a:p>
+            <a:pPr algn="l">
+              <a:spcAft>
+                <a:spcPts val="200"/>
+              </a:spcAft>
+            </a:pPr>
+            <a:r>
+              <a:rPr sz="1250" b="0">
+                <a:solidFill>
+                  <a:srgbClr val="16203C"/>
+                </a:solidFill>
+                <a:latin typeface="Calibri"/>
+              </a:rPr>
+              <a:t>The macro view shapes the advisory commentary. (12×)</a:t>
+            </a:r>
+          </a:p>
+        </p:txBody>
+      </p:sp>
+      <p:sp>
+        <p:nvSpPr>
+          <p:cNvPr id="14" name="Rectangle 13"/>
+          <p:cNvSpPr/>
+          <p:nvPr/>
+        </p:nvSpPr>
+        <p:spPr>
+          <a:xfrm>
+            <a:off x="640080" y="2807208"/>
+            <a:ext cx="10881360" cy="347472"/>
+          </a:xfrm>
+          <a:prstGeom prst="rect">
+            <a:avLst/>
+          </a:prstGeom>
+          <a:solidFill>
+            <a:srgbClr val="FFFFFF"/>
+          </a:solidFill>
+          <a:ln w="12700">
+            <a:solidFill>
+              <a:srgbClr val="C8CDDD"/>
+            </a:solidFill>
+          </a:ln>
+          <a:effectLst/>
+        </p:spPr>
+        <p:style>
+          <a:lnRef idx="1">
+            <a:schemeClr val="accent1"/>
+          </a:lnRef>
+          <a:fillRef idx="3">
+            <a:schemeClr val="accent1"/>
+          </a:fillRef>
+          <a:effectRef idx="2">
+            <a:schemeClr val="accent1"/>
+          </a:effectRef>
+          <a:fontRef idx="minor">
+            <a:schemeClr val="lt1"/>
+          </a:fontRef>
+        </p:style>
+        <p:txBody>
+          <a:bodyPr rtlCol="0" anchor="ctr"/>
+          <a:lstStyle/>
+          <a:p>
+            <a:pPr algn="ctr"/>
+          </a:p>
+        </p:txBody>
+      </p:sp>
+      <p:sp>
+        <p:nvSpPr>
+          <p:cNvPr id="15" name="TextBox 14"/>
+          <p:cNvSpPr txBox="1"/>
+          <p:nvPr/>
+        </p:nvSpPr>
+        <p:spPr>
+          <a:xfrm>
+            <a:off x="822960" y="2852928"/>
+            <a:ext cx="457200" cy="274320"/>
+          </a:xfrm>
+          <a:prstGeom prst="rect">
+            <a:avLst/>
+          </a:prstGeom>
+          <a:noFill/>
+        </p:spPr>
+        <p:txBody>
+          <a:bodyPr wrap="square" anchor="t" lIns="0" rIns="0" tIns="0" bIns="0">
+            <a:spAutoFit/>
+          </a:bodyPr>
+          <a:lstStyle/>
+          <a:p>
+            <a:pPr algn="l">
+              <a:spcAft>
+                <a:spcPts val="200"/>
+              </a:spcAft>
+            </a:pPr>
+            <a:r>
+              <a:rPr sz="1300" b="1">
+                <a:solidFill>
+                  <a:srgbClr val="2E7D52"/>
+                </a:solidFill>
+                <a:latin typeface="Calibri"/>
+              </a:rPr>
+              <a:t>✓</a:t>
+            </a:r>
+          </a:p>
+        </p:txBody>
+      </p:sp>
+      <p:sp>
+        <p:nvSpPr>
+          <p:cNvPr id="16" name="TextBox 15"/>
+          <p:cNvSpPr txBox="1"/>
+          <p:nvPr/>
+        </p:nvSpPr>
+        <p:spPr>
+          <a:xfrm>
+            <a:off x="1325880" y="2834640"/>
+            <a:ext cx="10058400" cy="365760"/>
+          </a:xfrm>
+          <a:prstGeom prst="rect">
+            <a:avLst/>
+          </a:prstGeom>
+          <a:noFill/>
+        </p:spPr>
+        <p:txBody>
+          <a:bodyPr wrap="square" anchor="ctr" lIns="0" rIns="0" tIns="0" bIns="0">
+            <a:spAutoFit/>
+          </a:bodyPr>
+          <a:lstStyle/>
+          <a:p>
+            <a:pPr algn="l">
+              <a:spcAft>
+                <a:spcPts val="200"/>
+              </a:spcAft>
+            </a:pPr>
+            <a:r>
+              <a:rPr sz="1250" b="0">
+                <a:solidFill>
+                  <a:srgbClr val="16203C"/>
+                </a:solidFill>
+                <a:latin typeface="Calibri"/>
+              </a:rPr>
+              <a:t>A macro opinion shapes prose, never figures: the FACTS block (every number the deck shows) is byte-for-byte identical with and without the scenario. (12×)</a:t>
+            </a:r>
+          </a:p>
+        </p:txBody>
+      </p:sp>
+      <p:sp>
+        <p:nvSpPr>
+          <p:cNvPr id="17" name="Rectangle 16"/>
+          <p:cNvSpPr/>
+          <p:nvPr/>
+        </p:nvSpPr>
+        <p:spPr>
+          <a:xfrm>
+            <a:off x="640080" y="3227832"/>
+            <a:ext cx="10881360" cy="347472"/>
+          </a:xfrm>
+          <a:prstGeom prst="rect">
+            <a:avLst/>
+          </a:prstGeom>
+          <a:solidFill>
+            <a:srgbClr val="F4F6FB"/>
+          </a:solidFill>
+          <a:ln w="12700">
+            <a:solidFill>
+              <a:srgbClr val="C8CDDD"/>
+            </a:solidFill>
+          </a:ln>
+          <a:effectLst/>
+        </p:spPr>
+        <p:style>
+          <a:lnRef idx="1">
+            <a:schemeClr val="accent1"/>
+          </a:lnRef>
+          <a:fillRef idx="3">
+            <a:schemeClr val="accent1"/>
+          </a:fillRef>
+          <a:effectRef idx="2">
+            <a:schemeClr val="accent1"/>
+          </a:effectRef>
+          <a:fontRef idx="minor">
+            <a:schemeClr val="lt1"/>
+          </a:fontRef>
+        </p:style>
+        <p:txBody>
+          <a:bodyPr rtlCol="0" anchor="ctr"/>
+          <a:lstStyle/>
+          <a:p>
+            <a:pPr algn="ctr"/>
+          </a:p>
+        </p:txBody>
+      </p:sp>
+      <p:sp>
+        <p:nvSpPr>
+          <p:cNvPr id="18" name="TextBox 17"/>
+          <p:cNvSpPr txBox="1"/>
+          <p:nvPr/>
+        </p:nvSpPr>
+        <p:spPr>
+          <a:xfrm>
+            <a:off x="822960" y="3273552"/>
+            <a:ext cx="457200" cy="274320"/>
+          </a:xfrm>
+          <a:prstGeom prst="rect">
+            <a:avLst/>
+          </a:prstGeom>
+          <a:noFill/>
+        </p:spPr>
+        <p:txBody>
+          <a:bodyPr wrap="square" anchor="t" lIns="0" rIns="0" tIns="0" bIns="0">
+            <a:spAutoFit/>
+          </a:bodyPr>
+          <a:lstStyle/>
+          <a:p>
+            <a:pPr algn="l">
+              <a:spcAft>
+                <a:spcPts val="200"/>
+              </a:spcAft>
+            </a:pPr>
+            <a:r>
+              <a:rPr sz="1300" b="1">
+                <a:solidFill>
+                  <a:srgbClr val="2E7D52"/>
+                </a:solidFill>
+                <a:latin typeface="Calibri"/>
+              </a:rPr>
+              <a:t>✓</a:t>
+            </a:r>
+          </a:p>
+        </p:txBody>
+      </p:sp>
+      <p:sp>
+        <p:nvSpPr>
+          <p:cNvPr id="19" name="TextBox 18"/>
+          <p:cNvSpPr txBox="1"/>
+          <p:nvPr/>
+        </p:nvSpPr>
+        <p:spPr>
+          <a:xfrm>
+            <a:off x="1325880" y="3255264"/>
+            <a:ext cx="10058400" cy="365760"/>
+          </a:xfrm>
+          <a:prstGeom prst="rect">
+            <a:avLst/>
+          </a:prstGeom>
+          <a:noFill/>
+        </p:spPr>
+        <p:txBody>
+          <a:bodyPr wrap="square" anchor="ctr" lIns="0" rIns="0" tIns="0" bIns="0">
+            <a:spAutoFit/>
+          </a:bodyPr>
+          <a:lstStyle/>
+          <a:p>
+            <a:pPr algn="l">
+              <a:spcAft>
+                <a:spcPts val="200"/>
+              </a:spcAft>
+            </a:pPr>
+            <a:r>
+              <a:rPr sz="1250" b="0">
+                <a:solidFill>
+                  <a:srgbClr val="16203C"/>
+                </a:solidFill>
+                <a:latin typeface="Calibri"/>
+              </a:rPr>
+              <a:t>'What if rates are hiked?' → the deterministic tool states the fixed-income exposure but refuses to estimate a +100bp impact it cannot source.</a:t>
+            </a:r>
+          </a:p>
+        </p:txBody>
+      </p:sp>
+      <p:sp>
+        <p:nvSpPr>
+          <p:cNvPr id="20" name="Rectangle 19"/>
+          <p:cNvSpPr/>
+          <p:nvPr/>
+        </p:nvSpPr>
+        <p:spPr>
+          <a:xfrm>
+            <a:off x="640080" y="3648456"/>
+            <a:ext cx="10881360" cy="347472"/>
+          </a:xfrm>
+          <a:prstGeom prst="rect">
+            <a:avLst/>
+          </a:prstGeom>
+          <a:solidFill>
+            <a:srgbClr val="FFFFFF"/>
+          </a:solidFill>
+          <a:ln w="12700">
+            <a:solidFill>
+              <a:srgbClr val="C8CDDD"/>
+            </a:solidFill>
+          </a:ln>
+          <a:effectLst/>
+        </p:spPr>
+        <p:style>
+          <a:lnRef idx="1">
+            <a:schemeClr val="accent1"/>
+          </a:lnRef>
+          <a:fillRef idx="3">
+            <a:schemeClr val="accent1"/>
+          </a:fillRef>
+          <a:effectRef idx="2">
+            <a:schemeClr val="accent1"/>
+          </a:effectRef>
+          <a:fontRef idx="minor">
+            <a:schemeClr val="lt1"/>
+          </a:fontRef>
+        </p:style>
+        <p:txBody>
+          <a:bodyPr rtlCol="0" anchor="ctr"/>
+          <a:lstStyle/>
+          <a:p>
+            <a:pPr algn="ctr"/>
+          </a:p>
+        </p:txBody>
+      </p:sp>
+      <p:sp>
+        <p:nvSpPr>
+          <p:cNvPr id="21" name="TextBox 20"/>
+          <p:cNvSpPr txBox="1"/>
+          <p:nvPr/>
+        </p:nvSpPr>
+        <p:spPr>
+          <a:xfrm>
+            <a:off x="822960" y="3694176"/>
+            <a:ext cx="457200" cy="274320"/>
+          </a:xfrm>
+          <a:prstGeom prst="rect">
+            <a:avLst/>
+          </a:prstGeom>
+          <a:noFill/>
+        </p:spPr>
+        <p:txBody>
+          <a:bodyPr wrap="square" anchor="t" lIns="0" rIns="0" tIns="0" bIns="0">
+            <a:spAutoFit/>
+          </a:bodyPr>
+          <a:lstStyle/>
+          <a:p>
+            <a:pPr algn="l">
+              <a:spcAft>
+                <a:spcPts val="200"/>
+              </a:spcAft>
+            </a:pPr>
+            <a:r>
+              <a:rPr sz="1300" b="1">
+                <a:solidFill>
+                  <a:srgbClr val="2E7D52"/>
+                </a:solidFill>
+                <a:latin typeface="Calibri"/>
+              </a:rPr>
+              <a:t>✓</a:t>
+            </a:r>
+          </a:p>
+        </p:txBody>
+      </p:sp>
+      <p:sp>
+        <p:nvSpPr>
+          <p:cNvPr id="22" name="TextBox 21"/>
+          <p:cNvSpPr txBox="1"/>
+          <p:nvPr/>
+        </p:nvSpPr>
+        <p:spPr>
+          <a:xfrm>
+            <a:off x="1325880" y="3675888"/>
+            <a:ext cx="10058400" cy="365760"/>
+          </a:xfrm>
+          <a:prstGeom prst="rect">
+            <a:avLst/>
+          </a:prstGeom>
+          <a:noFill/>
+        </p:spPr>
+        <p:txBody>
+          <a:bodyPr wrap="square" anchor="ctr" lIns="0" rIns="0" tIns="0" bIns="0">
+            <a:spAutoFit/>
+          </a:bodyPr>
+          <a:lstStyle/>
+          <a:p>
+            <a:pPr algn="l">
+              <a:spcAft>
+                <a:spcPts val="200"/>
+              </a:spcAft>
+            </a:pPr>
+            <a:r>
+              <a:rPr sz="1250" b="0">
+                <a:solidFill>
+                  <a:srgbClr val="16203C"/>
+                </a:solidFill>
+                <a:latin typeface="Calibri"/>
+              </a:rPr>
+              <a:t>A rate-move question routes to the rate tool.</a:t>
+            </a:r>
+          </a:p>
+        </p:txBody>
+      </p:sp>
+      <p:sp>
+        <p:nvSpPr>
+          <p:cNvPr id="23" name="Rectangle 22"/>
+          <p:cNvSpPr/>
+          <p:nvPr/>
+        </p:nvSpPr>
+        <p:spPr>
+          <a:xfrm>
+            <a:off x="640080" y="4069080"/>
+            <a:ext cx="10881360" cy="347472"/>
+          </a:xfrm>
+          <a:prstGeom prst="rect">
+            <a:avLst/>
+          </a:prstGeom>
+          <a:solidFill>
+            <a:srgbClr val="F4F6FB"/>
+          </a:solidFill>
+          <a:ln w="12700">
+            <a:solidFill>
+              <a:srgbClr val="C8CDDD"/>
+            </a:solidFill>
+          </a:ln>
+          <a:effectLst/>
+        </p:spPr>
+        <p:style>
+          <a:lnRef idx="1">
+            <a:schemeClr val="accent1"/>
+          </a:lnRef>
+          <a:fillRef idx="3">
+            <a:schemeClr val="accent1"/>
+          </a:fillRef>
+          <a:effectRef idx="2">
+            <a:schemeClr val="accent1"/>
+          </a:effectRef>
+          <a:fontRef idx="minor">
+            <a:schemeClr val="lt1"/>
+          </a:fontRef>
+        </p:style>
+        <p:txBody>
+          <a:bodyPr rtlCol="0" anchor="ctr"/>
+          <a:lstStyle/>
+          <a:p>
+            <a:pPr algn="ctr"/>
+          </a:p>
+        </p:txBody>
+      </p:sp>
+      <p:sp>
+        <p:nvSpPr>
+          <p:cNvPr id="24" name="TextBox 23"/>
+          <p:cNvSpPr txBox="1"/>
+          <p:nvPr/>
+        </p:nvSpPr>
+        <p:spPr>
+          <a:xfrm>
+            <a:off x="822960" y="4114800"/>
+            <a:ext cx="457200" cy="274320"/>
+          </a:xfrm>
+          <a:prstGeom prst="rect">
+            <a:avLst/>
+          </a:prstGeom>
+          <a:noFill/>
+        </p:spPr>
+        <p:txBody>
+          <a:bodyPr wrap="square" anchor="t" lIns="0" rIns="0" tIns="0" bIns="0">
+            <a:spAutoFit/>
+          </a:bodyPr>
+          <a:lstStyle/>
+          <a:p>
+            <a:pPr algn="l">
+              <a:spcAft>
+                <a:spcPts val="200"/>
+              </a:spcAft>
+            </a:pPr>
+            <a:r>
+              <a:rPr sz="1300" b="1">
+                <a:solidFill>
+                  <a:srgbClr val="2E7D52"/>
+                </a:solidFill>
+                <a:latin typeface="Calibri"/>
+              </a:rPr>
+              <a:t>✓</a:t>
+            </a:r>
+          </a:p>
+        </p:txBody>
+      </p:sp>
+      <p:sp>
+        <p:nvSpPr>
+          <p:cNvPr id="25" name="TextBox 24"/>
+          <p:cNvSpPr txBox="1"/>
+          <p:nvPr/>
+        </p:nvSpPr>
+        <p:spPr>
+          <a:xfrm>
+            <a:off x="1325880" y="4096512"/>
+            <a:ext cx="10058400" cy="365760"/>
+          </a:xfrm>
+          <a:prstGeom prst="rect">
+            <a:avLst/>
+          </a:prstGeom>
+          <a:noFill/>
+        </p:spPr>
+        <p:txBody>
+          <a:bodyPr wrap="square" anchor="ctr" lIns="0" rIns="0" tIns="0" bIns="0">
+            <a:spAutoFit/>
+          </a:bodyPr>
+          <a:lstStyle/>
+          <a:p>
+            <a:pPr algn="l">
+              <a:spcAft>
+                <a:spcPts val="200"/>
+              </a:spcAft>
+            </a:pPr>
+            <a:r>
+              <a:rPr sz="1250" b="0">
+                <a:solidFill>
+                  <a:srgbClr val="16203C"/>
+                </a:solidFill>
+                <a:latin typeface="Calibri"/>
+              </a:rPr>
+              <a:t>The scenario moves the deck's prose, not its tables.</a:t>
+            </a:r>
+          </a:p>
+        </p:txBody>
+      </p:sp>
+    </p:spTree>
+  </p:cSld>
+  <p:clrMapOvr>
+    <a:masterClrMapping/>
+  </p:clrMapOvr>
+</p:sld>
+</file>
+
+<file path=ppt/slides/slide11.xml><?xml version="1.0" encoding="utf-8"?>
+<p:sld xmlns:a="http://schemas.openxmlformats.org/drawingml/2006/main" xmlns:p="http://schemas.openxmlformats.org/presentationml/2006/main" xmlns:r="http://schemas.openxmlformats.org/officeDocument/2006/relationships">
+  <p:cSld>
+    <p:spTree>
+      <p:nvGrpSpPr>
+        <p:cNvPr id="1" name=""/>
+        <p:cNvGrpSpPr/>
+        <p:nvPr/>
+      </p:nvGrpSpPr>
+      <p:grpSpPr/>
+      <p:sp>
+        <p:nvSpPr>
+          <p:cNvPr id="2" name="Rectangle 1"/>
+          <p:cNvSpPr/>
+          <p:nvPr/>
+        </p:nvSpPr>
+        <p:spPr>
+          <a:xfrm>
+            <a:off x="0" y="0"/>
+            <a:ext cx="12191695" cy="6858000"/>
+          </a:xfrm>
+          <a:prstGeom prst="rect">
+            <a:avLst/>
+          </a:prstGeom>
+          <a:solidFill>
+            <a:srgbClr val="1E2A56"/>
+          </a:solidFill>
+          <a:ln>
+            <a:noFill/>
+          </a:ln>
+          <a:effectLst/>
+        </p:spPr>
+        <p:style>
+          <a:lnRef idx="1">
+            <a:schemeClr val="accent1"/>
+          </a:lnRef>
+          <a:fillRef idx="3">
+            <a:schemeClr val="accent1"/>
+          </a:fillRef>
+          <a:effectRef idx="2">
+            <a:schemeClr val="accent1"/>
+          </a:effectRef>
+          <a:fontRef idx="minor">
+            <a:schemeClr val="lt1"/>
+          </a:fontRef>
+        </p:style>
+        <p:txBody>
+          <a:bodyPr rtlCol="0" anchor="ctr"/>
+          <a:lstStyle/>
+          <a:p>
+            <a:pPr algn="ctr"/>
+          </a:p>
+        </p:txBody>
+      </p:sp>
+      <p:sp>
+        <p:nvSpPr>
+          <p:cNvPr id="3" name="Rectangle 2"/>
+          <p:cNvSpPr/>
+          <p:nvPr/>
+        </p:nvSpPr>
+        <p:spPr>
+          <a:xfrm>
+            <a:off x="0" y="6601968"/>
+            <a:ext cx="12191695" cy="256032"/>
+          </a:xfrm>
+          <a:prstGeom prst="rect">
+            <a:avLst/>
+          </a:prstGeom>
+          <a:solidFill>
+            <a:srgbClr val="B0872A"/>
+          </a:solidFill>
+          <a:ln>
+            <a:noFill/>
+          </a:ln>
+          <a:effectLst/>
+        </p:spPr>
+        <p:style>
+          <a:lnRef idx="1">
+            <a:schemeClr val="accent1"/>
+          </a:lnRef>
+          <a:fillRef idx="3">
+            <a:schemeClr val="accent1"/>
+          </a:fillRef>
+          <a:effectRef idx="2">
+            <a:schemeClr val="accent1"/>
+          </a:effectRef>
+          <a:fontRef idx="minor">
+            <a:schemeClr val="lt1"/>
+          </a:fontRef>
+        </p:style>
+        <p:txBody>
+          <a:bodyPr rtlCol="0" anchor="ctr"/>
+          <a:lstStyle/>
+          <a:p>
+            <a:pPr algn="ctr"/>
+          </a:p>
+        </p:txBody>
+      </p:sp>
+      <p:sp>
+        <p:nvSpPr>
+          <p:cNvPr id="4" name="TextBox 3"/>
+          <p:cNvSpPr txBox="1"/>
+          <p:nvPr/>
+        </p:nvSpPr>
+        <p:spPr>
+          <a:xfrm>
             <a:off x="822960" y="2377440"/>
             <a:ext cx="10515600" cy="914400"/>
           </a:xfrm>
@@ -3591,7 +4598,7 @@
                 </a:solidFill>
                 <a:latin typeface="Calibri"/>
               </a:rPr>
-              <a:t>69/69 passed  ·  offline, deterministic, repeatable</a:t>
+              <a:t>108/108 passed  ·  offline, deterministic, repeatable</a:t>
             </a:r>
           </a:p>
         </p:txBody>
@@ -3754,7 +4761,7 @@
         <p:spPr>
           <a:xfrm>
             <a:off x="640080" y="2103120"/>
-            <a:ext cx="3611880" cy="2377440"/>
+            <a:ext cx="2660904" cy="2377440"/>
           </a:xfrm>
           <a:prstGeom prst="rect">
             <a:avLst/>
@@ -3800,7 +4807,7 @@
         <p:spPr>
           <a:xfrm>
             <a:off x="640080" y="2103120"/>
-            <a:ext cx="3611880" cy="109728"/>
+            <a:ext cx="2660904" cy="109728"/>
           </a:xfrm>
           <a:prstGeom prst="rect">
             <a:avLst/>
@@ -3843,8 +4850,8 @@
         </p:nvSpPr>
         <p:spPr>
           <a:xfrm>
-            <a:off x="868680" y="2377440"/>
-            <a:ext cx="3154680" cy="457200"/>
+            <a:off x="822960" y="2377440"/>
+            <a:ext cx="2295144" cy="457200"/>
           </a:xfrm>
           <a:prstGeom prst="rect">
             <a:avLst/>
@@ -3863,7 +4870,7 @@
               </a:spcAft>
             </a:pPr>
             <a:r>
-              <a:rPr sz="2200" b="1">
+              <a:rPr sz="2000" b="1">
                 <a:solidFill>
                   <a:srgbClr val="1E2A56"/>
                 </a:solidFill>
@@ -3882,8 +4889,8 @@
         </p:nvSpPr>
         <p:spPr>
           <a:xfrm>
-            <a:off x="868680" y="2880360"/>
-            <a:ext cx="3154680" cy="365760"/>
+            <a:off x="822960" y="2852928"/>
+            <a:ext cx="2295144" cy="365760"/>
           </a:xfrm>
           <a:prstGeom prst="rect">
             <a:avLst/>
@@ -3902,7 +4909,7 @@
               </a:spcAft>
             </a:pPr>
             <a:r>
-              <a:rPr sz="1300" b="1">
+              <a:rPr sz="1200" b="1">
                 <a:solidFill>
                   <a:srgbClr val="B0872A"/>
                 </a:solidFill>
@@ -3921,8 +4928,8 @@
         </p:nvSpPr>
         <p:spPr>
           <a:xfrm>
-            <a:off x="868680" y="3383280"/>
-            <a:ext cx="3154680" cy="914400"/>
+            <a:off x="822960" y="3310128"/>
+            <a:ext cx="2295144" cy="1005840"/>
           </a:xfrm>
           <a:prstGeom prst="rect">
             <a:avLst/>
@@ -3941,7 +4948,7 @@
               </a:spcAft>
             </a:pPr>
             <a:r>
-              <a:rPr sz="1300" b="0">
+              <a:rPr sz="1200" b="0">
                 <a:solidFill>
                   <a:srgbClr val="47517A"/>
                 </a:solidFill>
@@ -3960,8 +4967,8 @@
         </p:nvSpPr>
         <p:spPr>
           <a:xfrm>
-            <a:off x="4343400" y="2103120"/>
-            <a:ext cx="3611880" cy="2377440"/>
+            <a:off x="3410712" y="2103120"/>
+            <a:ext cx="2660904" cy="2377440"/>
           </a:xfrm>
           <a:prstGeom prst="rect">
             <a:avLst/>
@@ -4006,8 +5013,8 @@
         </p:nvSpPr>
         <p:spPr>
           <a:xfrm>
-            <a:off x="4343400" y="2103120"/>
-            <a:ext cx="3611880" cy="109728"/>
+            <a:off x="3410712" y="2103120"/>
+            <a:ext cx="2660904" cy="109728"/>
           </a:xfrm>
           <a:prstGeom prst="rect">
             <a:avLst/>
@@ -4050,8 +5057,8 @@
         </p:nvSpPr>
         <p:spPr>
           <a:xfrm>
-            <a:off x="4572000" y="2377440"/>
-            <a:ext cx="3154680" cy="457200"/>
+            <a:off x="3593592" y="2377440"/>
+            <a:ext cx="2295144" cy="457200"/>
           </a:xfrm>
           <a:prstGeom prst="rect">
             <a:avLst/>
@@ -4070,7 +5077,7 @@
               </a:spcAft>
             </a:pPr>
             <a:r>
-              <a:rPr sz="2200" b="1">
+              <a:rPr sz="2000" b="1">
                 <a:solidFill>
                   <a:srgbClr val="1E2A56"/>
                 </a:solidFill>
@@ -4089,8 +5096,8 @@
         </p:nvSpPr>
         <p:spPr>
           <a:xfrm>
-            <a:off x="4572000" y="2880360"/>
-            <a:ext cx="3154680" cy="365760"/>
+            <a:off x="3593592" y="2852928"/>
+            <a:ext cx="2295144" cy="365760"/>
           </a:xfrm>
           <a:prstGeom prst="rect">
             <a:avLst/>
@@ -4109,13 +5116,13 @@
               </a:spcAft>
             </a:pPr>
             <a:r>
-              <a:rPr sz="1300" b="1">
+              <a:rPr sz="1200" b="1">
                 <a:solidFill>
                   <a:srgbClr val="B0872A"/>
                 </a:solidFill>
                 <a:latin typeface="Calibri"/>
               </a:rPr>
-              <a:t>3 files · 21 tests</a:t>
+              <a:t>3 files · 23 tests</a:t>
             </a:r>
           </a:p>
         </p:txBody>
@@ -4128,8 +5135,8 @@
         </p:nvSpPr>
         <p:spPr>
           <a:xfrm>
-            <a:off x="4572000" y="3383280"/>
-            <a:ext cx="3154680" cy="914400"/>
+            <a:off x="3593592" y="3310128"/>
+            <a:ext cx="2295144" cy="1005840"/>
           </a:xfrm>
           <a:prstGeom prst="rect">
             <a:avLst/>
@@ -4148,7 +5155,7 @@
               </a:spcAft>
             </a:pPr>
             <a:r>
-              <a:rPr sz="1300" b="0">
+              <a:rPr sz="1200" b="0">
                 <a:solidFill>
                   <a:srgbClr val="47517A"/>
                 </a:solidFill>
@@ -4167,8 +5174,8 @@
         </p:nvSpPr>
         <p:spPr>
           <a:xfrm>
-            <a:off x="8046720" y="2103120"/>
-            <a:ext cx="3611880" cy="2377440"/>
+            <a:off x="6181344" y="2103120"/>
+            <a:ext cx="2660904" cy="2377440"/>
           </a:xfrm>
           <a:prstGeom prst="rect">
             <a:avLst/>
@@ -4213,8 +5220,8 @@
         </p:nvSpPr>
         <p:spPr>
           <a:xfrm>
-            <a:off x="8046720" y="2103120"/>
-            <a:ext cx="3611880" cy="109728"/>
+            <a:off x="6181344" y="2103120"/>
+            <a:ext cx="2660904" cy="109728"/>
           </a:xfrm>
           <a:prstGeom prst="rect">
             <a:avLst/>
@@ -4257,8 +5264,8 @@
         </p:nvSpPr>
         <p:spPr>
           <a:xfrm>
-            <a:off x="8275320" y="2377440"/>
-            <a:ext cx="3154680" cy="457200"/>
+            <a:off x="6364224" y="2377440"/>
+            <a:ext cx="2295144" cy="457200"/>
           </a:xfrm>
           <a:prstGeom prst="rect">
             <a:avLst/>
@@ -4277,7 +5284,7 @@
               </a:spcAft>
             </a:pPr>
             <a:r>
-              <a:rPr sz="2200" b="1">
+              <a:rPr sz="2000" b="1">
                 <a:solidFill>
                   <a:srgbClr val="1E2A56"/>
                 </a:solidFill>
@@ -4296,8 +5303,8 @@
         </p:nvSpPr>
         <p:spPr>
           <a:xfrm>
-            <a:off x="8275320" y="2880360"/>
-            <a:ext cx="3154680" cy="365760"/>
+            <a:off x="6364224" y="2852928"/>
+            <a:ext cx="2295144" cy="365760"/>
           </a:xfrm>
           <a:prstGeom prst="rect">
             <a:avLst/>
@@ -4316,13 +5323,13 @@
               </a:spcAft>
             </a:pPr>
             <a:r>
-              <a:rPr sz="1300" b="1">
+              <a:rPr sz="1200" b="1">
                 <a:solidFill>
                   <a:srgbClr val="B0872A"/>
                 </a:solidFill>
                 <a:latin typeface="Calibri"/>
               </a:rPr>
-              <a:t>1 file · 14 tests</a:t>
+              <a:t>1 file · 16 tests</a:t>
             </a:r>
           </a:p>
         </p:txBody>
@@ -4335,8 +5342,8 @@
         </p:nvSpPr>
         <p:spPr>
           <a:xfrm>
-            <a:off x="8275320" y="3383280"/>
-            <a:ext cx="3154680" cy="914400"/>
+            <a:off x="6364224" y="3310128"/>
+            <a:ext cx="2295144" cy="1005840"/>
           </a:xfrm>
           <a:prstGeom prst="rect">
             <a:avLst/>
@@ -4355,7 +5362,7 @@
               </a:spcAft>
             </a:pPr>
             <a:r>
-              <a:rPr sz="1300" b="0">
+              <a:rPr sz="1200" b="0">
                 <a:solidFill>
                   <a:srgbClr val="47517A"/>
                 </a:solidFill>
@@ -4368,7 +5375,214 @@
       </p:sp>
       <p:sp>
         <p:nvSpPr>
-          <p:cNvPr id="20" name="TextBox 19"/>
+          <p:cNvPr id="20" name="Rectangle 19"/>
+          <p:cNvSpPr/>
+          <p:nvPr/>
+        </p:nvSpPr>
+        <p:spPr>
+          <a:xfrm>
+            <a:off x="8951976" y="2103120"/>
+            <a:ext cx="2660904" cy="2377440"/>
+          </a:xfrm>
+          <a:prstGeom prst="rect">
+            <a:avLst/>
+          </a:prstGeom>
+          <a:solidFill>
+            <a:srgbClr val="F4F6FB"/>
+          </a:solidFill>
+          <a:ln w="12700">
+            <a:solidFill>
+              <a:srgbClr val="C8CDDD"/>
+            </a:solidFill>
+          </a:ln>
+          <a:effectLst/>
+        </p:spPr>
+        <p:style>
+          <a:lnRef idx="1">
+            <a:schemeClr val="accent1"/>
+          </a:lnRef>
+          <a:fillRef idx="3">
+            <a:schemeClr val="accent1"/>
+          </a:fillRef>
+          <a:effectRef idx="2">
+            <a:schemeClr val="accent1"/>
+          </a:effectRef>
+          <a:fontRef idx="minor">
+            <a:schemeClr val="lt1"/>
+          </a:fontRef>
+        </p:style>
+        <p:txBody>
+          <a:bodyPr rtlCol="0" anchor="ctr"/>
+          <a:lstStyle/>
+          <a:p>
+            <a:pPr algn="ctr"/>
+          </a:p>
+        </p:txBody>
+      </p:sp>
+      <p:sp>
+        <p:nvSpPr>
+          <p:cNvPr id="21" name="Rectangle 20"/>
+          <p:cNvSpPr/>
+          <p:nvPr/>
+        </p:nvSpPr>
+        <p:spPr>
+          <a:xfrm>
+            <a:off x="8951976" y="2103120"/>
+            <a:ext cx="2660904" cy="109728"/>
+          </a:xfrm>
+          <a:prstGeom prst="rect">
+            <a:avLst/>
+          </a:prstGeom>
+          <a:solidFill>
+            <a:srgbClr val="B0872A"/>
+          </a:solidFill>
+          <a:ln>
+            <a:noFill/>
+          </a:ln>
+          <a:effectLst/>
+        </p:spPr>
+        <p:style>
+          <a:lnRef idx="1">
+            <a:schemeClr val="accent1"/>
+          </a:lnRef>
+          <a:fillRef idx="3">
+            <a:schemeClr val="accent1"/>
+          </a:fillRef>
+          <a:effectRef idx="2">
+            <a:schemeClr val="accent1"/>
+          </a:effectRef>
+          <a:fontRef idx="minor">
+            <a:schemeClr val="lt1"/>
+          </a:fontRef>
+        </p:style>
+        <p:txBody>
+          <a:bodyPr rtlCol="0" anchor="ctr"/>
+          <a:lstStyle/>
+          <a:p>
+            <a:pPr algn="ctr"/>
+          </a:p>
+        </p:txBody>
+      </p:sp>
+      <p:sp>
+        <p:nvSpPr>
+          <p:cNvPr id="22" name="TextBox 21"/>
+          <p:cNvSpPr txBox="1"/>
+          <p:nvPr/>
+        </p:nvSpPr>
+        <p:spPr>
+          <a:xfrm>
+            <a:off x="9134856" y="2377440"/>
+            <a:ext cx="2295144" cy="457200"/>
+          </a:xfrm>
+          <a:prstGeom prst="rect">
+            <a:avLst/>
+          </a:prstGeom>
+          <a:noFill/>
+        </p:spPr>
+        <p:txBody>
+          <a:bodyPr wrap="square" anchor="t" lIns="0" rIns="0" tIns="0" bIns="0">
+            <a:spAutoFit/>
+          </a:bodyPr>
+          <a:lstStyle/>
+          <a:p>
+            <a:pPr algn="l">
+              <a:spcAft>
+                <a:spcPts val="200"/>
+              </a:spcAft>
+            </a:pPr>
+            <a:r>
+              <a:rPr sz="2000" b="1">
+                <a:solidFill>
+                  <a:srgbClr val="1E2A56"/>
+                </a:solidFill>
+                <a:latin typeface="Calibri"/>
+              </a:rPr>
+              <a:t>Business</a:t>
+            </a:r>
+          </a:p>
+        </p:txBody>
+      </p:sp>
+      <p:sp>
+        <p:nvSpPr>
+          <p:cNvPr id="23" name="TextBox 22"/>
+          <p:cNvSpPr txBox="1"/>
+          <p:nvPr/>
+        </p:nvSpPr>
+        <p:spPr>
+          <a:xfrm>
+            <a:off x="9134856" y="2852928"/>
+            <a:ext cx="2295144" cy="365760"/>
+          </a:xfrm>
+          <a:prstGeom prst="rect">
+            <a:avLst/>
+          </a:prstGeom>
+          <a:noFill/>
+        </p:spPr>
+        <p:txBody>
+          <a:bodyPr wrap="square" anchor="t" lIns="0" rIns="0" tIns="0" bIns="0">
+            <a:spAutoFit/>
+          </a:bodyPr>
+          <a:lstStyle/>
+          <a:p>
+            <a:pPr algn="l">
+              <a:spcAft>
+                <a:spcPts val="200"/>
+              </a:spcAft>
+            </a:pPr>
+            <a:r>
+              <a:rPr sz="1200" b="1">
+                <a:solidFill>
+                  <a:srgbClr val="B0872A"/>
+                </a:solidFill>
+                <a:latin typeface="Calibri"/>
+              </a:rPr>
+              <a:t>1 file · 39 tests</a:t>
+            </a:r>
+          </a:p>
+        </p:txBody>
+      </p:sp>
+      <p:sp>
+        <p:nvSpPr>
+          <p:cNvPr id="24" name="TextBox 23"/>
+          <p:cNvSpPr txBox="1"/>
+          <p:nvPr/>
+        </p:nvSpPr>
+        <p:spPr>
+          <a:xfrm>
+            <a:off x="9134856" y="3310128"/>
+            <a:ext cx="2295144" cy="1005840"/>
+          </a:xfrm>
+          <a:prstGeom prst="rect">
+            <a:avLst/>
+          </a:prstGeom>
+          <a:noFill/>
+        </p:spPr>
+        <p:txBody>
+          <a:bodyPr wrap="square" anchor="t" lIns="0" rIns="0" tIns="0" bIns="0">
+            <a:spAutoFit/>
+          </a:bodyPr>
+          <a:lstStyle/>
+          <a:p>
+            <a:pPr algn="l">
+              <a:spcAft>
+                <a:spcPts val="200"/>
+              </a:spcAft>
+            </a:pPr>
+            <a:r>
+              <a:rPr sz="1200" b="0">
+                <a:solidFill>
+                  <a:srgbClr val="47517A"/>
+                </a:solidFill>
+                <a:latin typeface="Calibri"/>
+              </a:rPr>
+              <a:t>Client macro views: rates · war · tax → prose, not the numbers</a:t>
+            </a:r>
+          </a:p>
+        </p:txBody>
+      </p:sp>
+      <p:sp>
+        <p:nvSpPr>
+          <p:cNvPr id="25" name="TextBox 24"/>
           <p:cNvSpPr txBox="1"/>
           <p:nvPr/>
         </p:nvSpPr>
@@ -4449,6 +5663,22 @@
                 <a:latin typeface="Calibri"/>
               </a:rPr>
               <a:t>• Reconciliation catches the ~$436 custodian break instead of trusting it silently.</a:t>
+            </a:r>
+          </a:p>
+          <a:p>
+            <a:pPr algn="l">
+              <a:spcAft>
+                <a:spcPts val="600"/>
+              </a:spcAft>
+            </a:pPr>
+            <a:r>
+              <a:rPr sz="1250" b="0">
+                <a:solidFill>
+                  <a:srgbClr val="16203C"/>
+                </a:solidFill>
+                <a:latin typeface="Calibri"/>
+              </a:rPr>
+              <a:t>• A client macro view (rate hike/cut, war, tax change) reshapes the commentary but never moves the grounded figures.</a:t>
             </a:r>
           </a:p>
         </p:txBody>

</xml_diff>